<commit_message>
Commented out the section that was killing the ram
</commit_message>
<xml_diff>
--- a/data_visualization_slides.pptx
+++ b/data_visualization_slides.pptx
@@ -10,7 +10,7 @@
   <p:sldIdLst>
     <p:sldId id="256" r:id="rId2"/>
     <p:sldId id="257" r:id="rId3"/>
-    <p:sldId id="258" r:id="rId4"/>
+    <p:sldId id="267" r:id="rId4"/>
     <p:sldId id="260" r:id="rId5"/>
     <p:sldId id="261" r:id="rId6"/>
     <p:sldId id="262" r:id="rId7"/>
@@ -3287,6 +3287,64 @@
       </p:grpSpPr>
       <p:sp>
         <p:nvSpPr>
+          <p:cNvPr id="18" name="Arrow: Bent 17">
+            <a:extLst>
+              <a:ext uri="{FF2B5EF4-FFF2-40B4-BE49-F238E27FC236}">
+                <a16:creationId xmlns:a16="http://schemas.microsoft.com/office/drawing/2014/main" id="{436826A3-FDC9-47F0-8F54-76F7FB9B1E11}"/>
+              </a:ext>
+            </a:extLst>
+          </p:cNvPr>
+          <p:cNvSpPr/>
+          <p:nvPr/>
+        </p:nvSpPr>
+        <p:spPr>
+          <a:xfrm rot="5400000">
+            <a:off x="5389880" y="292101"/>
+            <a:ext cx="764539" cy="2872740"/>
+          </a:xfrm>
+          <a:prstGeom prst="bentArrow">
+            <a:avLst/>
+          </a:prstGeom>
+          <a:solidFill>
+            <a:srgbClr val="0F8A7E"/>
+          </a:solidFill>
+          <a:ln w="12700" cap="flat" cmpd="sng" algn="ctr">
+            <a:noFill/>
+            <a:prstDash val="solid"/>
+            <a:miter lim="800000"/>
+          </a:ln>
+        </p:spPr>
+        <p:style>
+          <a:lnRef idx="2">
+            <a:schemeClr val="accent1">
+              <a:shade val="15000"/>
+            </a:schemeClr>
+          </a:lnRef>
+          <a:fillRef idx="1">
+            <a:schemeClr val="accent1"/>
+          </a:fillRef>
+          <a:effectRef idx="0">
+            <a:schemeClr val="accent1"/>
+          </a:effectRef>
+          <a:fontRef idx="minor">
+            <a:schemeClr val="lt1"/>
+          </a:fontRef>
+        </p:style>
+        <p:txBody>
+          <a:bodyPr vertOverflow="clip" horzOverflow="clip" rtlCol="0" anchor="t"/>
+          <a:lstStyle/>
+          <a:p>
+            <a:pPr algn="l"/>
+            <a:endParaRPr lang="en-GB">
+              <a:solidFill>
+                <a:schemeClr val="tx1"/>
+              </a:solidFill>
+            </a:endParaRPr>
+          </a:p>
+        </p:txBody>
+      </p:sp>
+      <p:sp>
+        <p:nvSpPr>
           <p:cNvPr id="2" name="Shape 0"/>
           <p:cNvSpPr/>
           <p:nvPr/>
@@ -3901,7 +3959,69 @@
           </a:p>
         </p:txBody>
       </p:sp>
+      <p:sp>
+        <p:nvSpPr>
+          <p:cNvPr id="19" name="Arrow: Bent 18">
+            <a:extLst>
+              <a:ext uri="{FF2B5EF4-FFF2-40B4-BE49-F238E27FC236}">
+                <a16:creationId xmlns:a16="http://schemas.microsoft.com/office/drawing/2014/main" id="{3F79B18D-276B-4A47-9F7F-825EE996C8DC}"/>
+              </a:ext>
+            </a:extLst>
+          </p:cNvPr>
+          <p:cNvSpPr/>
+          <p:nvPr/>
+        </p:nvSpPr>
+        <p:spPr>
+          <a:xfrm rot="10800000">
+            <a:off x="4549139" y="3256787"/>
+            <a:ext cx="2599219" cy="964693"/>
+          </a:xfrm>
+          <a:prstGeom prst="bentArrow">
+            <a:avLst/>
+          </a:prstGeom>
+          <a:solidFill>
+            <a:srgbClr val="0F8A7E"/>
+          </a:solidFill>
+          <a:ln w="12700" cap="flat" cmpd="sng" algn="ctr">
+            <a:noFill/>
+            <a:prstDash val="solid"/>
+            <a:miter lim="800000"/>
+          </a:ln>
+        </p:spPr>
+        <p:style>
+          <a:lnRef idx="2">
+            <a:schemeClr val="accent1">
+              <a:shade val="15000"/>
+            </a:schemeClr>
+          </a:lnRef>
+          <a:fillRef idx="1">
+            <a:schemeClr val="accent1"/>
+          </a:fillRef>
+          <a:effectRef idx="0">
+            <a:schemeClr val="accent1"/>
+          </a:effectRef>
+          <a:fontRef idx="minor">
+            <a:schemeClr val="lt1"/>
+          </a:fontRef>
+        </p:style>
+        <p:txBody>
+          <a:bodyPr vertOverflow="clip" horzOverflow="clip" rtlCol="0" anchor="t"/>
+          <a:lstStyle/>
+          <a:p>
+            <a:endParaRPr lang="en-GB">
+              <a:solidFill>
+                <a:schemeClr val="tx1"/>
+              </a:solidFill>
+            </a:endParaRPr>
+          </a:p>
+        </p:txBody>
+      </p:sp>
     </p:spTree>
+    <p:extLst>
+      <p:ext uri="{BB962C8B-B14F-4D97-AF65-F5344CB8AC3E}">
+        <p14:creationId xmlns:p14="http://schemas.microsoft.com/office/powerpoint/2010/main" val="1268945029"/>
+      </p:ext>
+    </p:extLst>
   </p:cSld>
   <p:clrMapOvr>
     <a:masterClrMapping/>
@@ -9462,4 +9582,26 @@
     </a:ext>
   </a:extLst>
 </a:theme>
+</file>
+
+<file path=ppt/webextensions/taskpanes.xml><?xml version="1.0" encoding="utf-8"?>
+<wetp:taskpanes xmlns:wetp="http://schemas.microsoft.com/office/webextensions/taskpanes/2010/11">
+  <wetp:taskpane dockstate="right" visibility="0" width="438" row="0">
+    <wetp:webextensionref xmlns:r="http://schemas.openxmlformats.org/officeDocument/2006/relationships" r:id="rId1"/>
+  </wetp:taskpane>
+</wetp:taskpanes>
+</file>
+
+<file path=ppt/webextensions/webextension1.xml><?xml version="1.0" encoding="utf-8"?>
+<we:webextension xmlns:we="http://schemas.microsoft.com/office/webextensions/webextension/2010/11" id="{9E86CAE9-3DEA-4231-B6AA-9C8C907F9A7B}">
+  <we:reference id="WA200010001" version="1.0.0.1" store="Omex" storeType="OMEX"/>
+  <we:alternateReferences>
+    <we:reference id="WA200010001" version="1.0.0.1" store="WA200010001" storeType="OMEX"/>
+  </we:alternateReferences>
+  <we:properties>
+    <we:property name="claude.fileId" value="&quot;b4a3b6f7-4fb3-4d5e-819e-ad74007ded32&quot;"/>
+  </we:properties>
+  <we:bindings/>
+  <we:snapshot xmlns:r="http://schemas.openxmlformats.org/officeDocument/2006/relationships"/>
+</we:webextension>
 </file>
</xml_diff>